<commit_message>
Fig. 1: FWA CPE served in the NCR cell; orthogonal OFDMA sub-band inset
Site 1 now serves an in-cell rooftop CPE alongside hosting the NCR, so
the figure shows both capacity mechanisms coexisting under one gNB
rather than implying FWA lives only at the cell boundary. Scenery
reshuffled to keep the new beam angularly clear of the other-site
interference beam. New top-left inset states the frequency plan
qualitatively: cellular UEs and FWA CPEs occupy disjoint OFDMA
sub-bands, so no cross-service interference exists and only the
co-channel terms drawn in the scene remain. EPS re-exported at IEEE
double-column width (7.16 x 2.98 in).

Co-Authored-By: Claude Opus 5 <noreply@anthropic.com>
</commit_message>
<xml_diff>
--- a/diagrams/deployment_model.pptx
+++ b/diagrams/deployment_model.pptx
@@ -989,7 +989,7 @@
         </p:blipFill>
         <p:spPr>
           <a:xfrm>
-            <a:off x="3928044" y="2715768"/>
+            <a:off x="3790884" y="2852928"/>
             <a:ext cx="556392" cy="530352"/>
           </a:xfrm>
           <a:prstGeom prst="rect">
@@ -1013,7 +1013,7 @@
         </p:blipFill>
         <p:spPr>
           <a:xfrm>
-            <a:off x="3713086" y="2514600"/>
+            <a:off x="3639934" y="2560320"/>
             <a:ext cx="218212" cy="365760"/>
           </a:xfrm>
           <a:prstGeom prst="rect">
@@ -1037,7 +1037,7 @@
         </p:blipFill>
         <p:spPr>
           <a:xfrm>
-            <a:off x="4705284" y="3236976"/>
+            <a:off x="3013644" y="3584448"/>
             <a:ext cx="556392" cy="530352"/>
           </a:xfrm>
           <a:prstGeom prst="rect">
@@ -1450,9 +1450,38 @@
           </a:ln>
         </p:spPr>
       </p:sp>
+      <p:sp>
+        <p:nvSpPr>
+          <p:cNvPr id="25" name="Shape 11"/>
+          <p:cNvSpPr/>
+          <p:nvPr/>
+        </p:nvSpPr>
+        <p:spPr>
+          <a:xfrm rot="-2931521">
+            <a:off x="3714841" y="1192847"/>
+            <a:ext cx="274320" cy="1900464"/>
+          </a:xfrm>
+          <a:prstGeom prst="triangle">
+            <a:avLst/>
+          </a:prstGeom>
+          <a:solidFill>
+            <a:srgbClr val="0073BA">
+              <a:alpha val="45000"/>
+            </a:srgbClr>
+          </a:solidFill>
+          <a:ln w="9525">
+            <a:solidFill>
+              <a:srgbClr val="0073BA">
+                <a:alpha val="75000"/>
+              </a:srgbClr>
+            </a:solidFill>
+            <a:prstDash val="solid"/>
+          </a:ln>
+        </p:spPr>
+      </p:sp>
       <p:pic>
         <p:nvPicPr>
-          <p:cNvPr id="25" name="Image 12" descr="preencoded.png">    </p:cNvPr>
+          <p:cNvPr id="26" name="Image 12" descr="preencoded.png">    </p:cNvPr>
           <p:cNvPicPr>
             <a:picLocks noChangeAspect="1"/>
           </p:cNvPicPr>
@@ -1476,7 +1505,7 @@
       </p:pic>
       <p:pic>
         <p:nvPicPr>
-          <p:cNvPr id="26" name="Image 13" descr="preencoded.png">    </p:cNvPr>
+          <p:cNvPr id="27" name="Image 13" descr="preencoded.png">    </p:cNvPr>
           <p:cNvPicPr>
             <a:picLocks noChangeAspect="1"/>
           </p:cNvPicPr>
@@ -1500,7 +1529,7 @@
       </p:pic>
       <p:pic>
         <p:nvPicPr>
-          <p:cNvPr id="27" name="Image 14" descr="preencoded.png">    </p:cNvPr>
+          <p:cNvPr id="28" name="Image 14" descr="preencoded.png">    </p:cNvPr>
           <p:cNvPicPr>
             <a:picLocks noChangeAspect="1"/>
           </p:cNvPicPr>
@@ -1524,7 +1553,7 @@
       </p:pic>
       <p:sp>
         <p:nvSpPr>
-          <p:cNvPr id="28" name="Shape 11"/>
+          <p:cNvPr id="29" name="Shape 12"/>
           <p:cNvSpPr/>
           <p:nvPr/>
         </p:nvSpPr>
@@ -1544,7 +1573,7 @@
       </p:sp>
       <p:pic>
         <p:nvPicPr>
-          <p:cNvPr id="29" name="Image 15" descr="preencoded.png">    </p:cNvPr>
+          <p:cNvPr id="30" name="Image 15" descr="preencoded.png">    </p:cNvPr>
           <p:cNvPicPr>
             <a:picLocks noChangeAspect="1"/>
           </p:cNvPicPr>
@@ -1568,7 +1597,7 @@
       </p:pic>
       <p:pic>
         <p:nvPicPr>
-          <p:cNvPr id="30" name="Image 16" descr="preencoded.png">    </p:cNvPr>
+          <p:cNvPr id="31" name="Image 16" descr="preencoded.png">    </p:cNvPr>
           <p:cNvPicPr>
             <a:picLocks noChangeAspect="1"/>
           </p:cNvPicPr>
@@ -1592,7 +1621,7 @@
       </p:pic>
       <p:pic>
         <p:nvPicPr>
-          <p:cNvPr id="31" name="Image 17" descr="preencoded.png">    </p:cNvPr>
+          <p:cNvPr id="32" name="Image 17" descr="preencoded.png">    </p:cNvPr>
           <p:cNvPicPr>
             <a:picLocks noChangeAspect="1"/>
           </p:cNvPicPr>
@@ -1606,6 +1635,54 @@
         </p:blipFill>
         <p:spPr>
           <a:xfrm>
+            <a:off x="4522404" y="3081528"/>
+            <a:ext cx="556392" cy="530352"/>
+          </a:xfrm>
+          <a:prstGeom prst="rect">
+            <a:avLst/>
+          </a:prstGeom>
+        </p:spPr>
+      </p:pic>
+      <p:pic>
+        <p:nvPicPr>
+          <p:cNvPr id="33" name="Image 18" descr="preencoded.png">    </p:cNvPr>
+          <p:cNvPicPr>
+            <a:picLocks noChangeAspect="1"/>
+          </p:cNvPicPr>
+          <p:nvPr/>
+        </p:nvPicPr>
+        <p:blipFill>
+          <a:blip r:embed="rId19"/>
+          <a:stretch>
+            <a:fillRect/>
+          </a:stretch>
+        </p:blipFill>
+        <p:spPr>
+          <a:xfrm>
+            <a:off x="4644468" y="2779776"/>
+            <a:ext cx="312264" cy="329184"/>
+          </a:xfrm>
+          <a:prstGeom prst="rect">
+            <a:avLst/>
+          </a:prstGeom>
+        </p:spPr>
+      </p:pic>
+      <p:pic>
+        <p:nvPicPr>
+          <p:cNvPr id="34" name="Image 19" descr="preencoded.png">    </p:cNvPr>
+          <p:cNvPicPr>
+            <a:picLocks noChangeAspect="1"/>
+          </p:cNvPicPr>
+          <p:nvPr/>
+        </p:nvPicPr>
+        <p:blipFill>
+          <a:blip r:embed="rId20"/>
+          <a:stretch>
+            <a:fillRect/>
+          </a:stretch>
+        </p:blipFill>
+        <p:spPr>
+          <a:xfrm>
             <a:off x="869758" y="3429000"/>
             <a:ext cx="637924" cy="347472"/>
           </a:xfrm>
@@ -1616,7 +1693,7 @@
       </p:pic>
       <p:sp>
         <p:nvSpPr>
-          <p:cNvPr id="32" name="Text 12"/>
+          <p:cNvPr id="35" name="Text 13"/>
           <p:cNvSpPr/>
           <p:nvPr/>
         </p:nvSpPr>
@@ -1655,7 +1732,7 @@
       </p:sp>
       <p:sp>
         <p:nvSpPr>
-          <p:cNvPr id="33" name="Text 13"/>
+          <p:cNvPr id="36" name="Text 14"/>
           <p:cNvSpPr/>
           <p:nvPr/>
         </p:nvSpPr>
@@ -1694,7 +1771,7 @@
       </p:sp>
       <p:sp>
         <p:nvSpPr>
-          <p:cNvPr id="34" name="Text 14"/>
+          <p:cNvPr id="37" name="Text 15"/>
           <p:cNvSpPr/>
           <p:nvPr/>
         </p:nvSpPr>
@@ -1733,7 +1810,7 @@
       </p:sp>
       <p:sp>
         <p:nvSpPr>
-          <p:cNvPr id="35" name="Text 15"/>
+          <p:cNvPr id="38" name="Text 16"/>
           <p:cNvSpPr/>
           <p:nvPr/>
         </p:nvSpPr>
@@ -1772,7 +1849,7 @@
       </p:sp>
       <p:sp>
         <p:nvSpPr>
-          <p:cNvPr id="36" name="Text 16"/>
+          <p:cNvPr id="39" name="Text 17"/>
           <p:cNvSpPr/>
           <p:nvPr/>
         </p:nvSpPr>
@@ -1811,7 +1888,7 @@
       </p:sp>
       <p:sp>
         <p:nvSpPr>
-          <p:cNvPr id="37" name="Text 17"/>
+          <p:cNvPr id="40" name="Text 18"/>
           <p:cNvSpPr/>
           <p:nvPr/>
         </p:nvSpPr>
@@ -1850,7 +1927,7 @@
       </p:sp>
       <p:sp>
         <p:nvSpPr>
-          <p:cNvPr id="38" name="Text 18"/>
+          <p:cNvPr id="41" name="Text 19"/>
           <p:cNvSpPr/>
           <p:nvPr/>
         </p:nvSpPr>
@@ -1889,7 +1966,7 @@
       </p:sp>
       <p:sp>
         <p:nvSpPr>
-          <p:cNvPr id="39" name="Text 19"/>
+          <p:cNvPr id="42" name="Text 20"/>
           <p:cNvSpPr/>
           <p:nvPr/>
         </p:nvSpPr>
@@ -1926,16 +2003,285 @@
           </a:p>
         </p:txBody>
       </p:sp>
+      <p:sp>
+        <p:nvSpPr>
+          <p:cNvPr id="43" name="Text 21"/>
+          <p:cNvSpPr/>
+          <p:nvPr/>
+        </p:nvSpPr>
+        <p:spPr>
+          <a:xfrm>
+            <a:off x="4251960" y="3657600"/>
+            <a:ext cx="1097280" cy="201168"/>
+          </a:xfrm>
+          <a:prstGeom prst="rect">
+            <a:avLst/>
+          </a:prstGeom>
+          <a:noFill/>
+          <a:ln/>
+        </p:spPr>
+        <p:txBody>
+          <a:bodyPr wrap="square" lIns="0" tIns="0" rIns="0" bIns="0" rtlCol="0" anchor="ctr"/>
+          <a:lstStyle/>
+          <a:p>
+            <a:pPr algn="ctr" indent="0" marL="0">
+              <a:buNone/>
+            </a:pPr>
+            <a:r>
+              <a:rPr lang="en-US" sz="1200" b="1" dirty="0">
+                <a:solidFill>
+                  <a:srgbClr val="1A1A1A"/>
+                </a:solidFill>
+                <a:latin typeface="Times New Roman" pitchFamily="34" charset="0"/>
+                <a:ea typeface="Times New Roman" pitchFamily="34" charset="-122"/>
+                <a:cs typeface="Times New Roman" pitchFamily="34" charset="-120"/>
+              </a:rPr>
+              <a:t>FWA CPE</a:t>
+            </a:r>
+            <a:endParaRPr lang="en-US" sz="1200" dirty="0"/>
+          </a:p>
+        </p:txBody>
+      </p:sp>
+      <p:sp>
+        <p:nvSpPr>
+          <p:cNvPr id="44" name="Text 22"/>
+          <p:cNvSpPr/>
+          <p:nvPr/>
+        </p:nvSpPr>
+        <p:spPr>
+          <a:xfrm>
+            <a:off x="274320" y="237744"/>
+            <a:ext cx="2011680" cy="201168"/>
+          </a:xfrm>
+          <a:prstGeom prst="rect">
+            <a:avLst/>
+          </a:prstGeom>
+          <a:noFill/>
+          <a:ln/>
+        </p:spPr>
+        <p:txBody>
+          <a:bodyPr wrap="square" lIns="0" tIns="0" rIns="0" bIns="0" rtlCol="0" anchor="ctr"/>
+          <a:lstStyle/>
+          <a:p>
+            <a:pPr algn="ctr" indent="0" marL="0">
+              <a:buNone/>
+            </a:pPr>
+            <a:r>
+              <a:rPr lang="en-US" sz="1100" b="1" dirty="0">
+                <a:solidFill>
+                  <a:srgbClr val="1A1A1A"/>
+                </a:solidFill>
+                <a:latin typeface="Times New Roman" pitchFamily="34" charset="0"/>
+                <a:ea typeface="Times New Roman" pitchFamily="34" charset="-122"/>
+                <a:cs typeface="Times New Roman" pitchFamily="34" charset="-120"/>
+              </a:rPr>
+              <a:t>Orthogonal OFDMA sub-bands</a:t>
+            </a:r>
+            <a:endParaRPr lang="en-US" sz="1100" dirty="0"/>
+          </a:p>
+        </p:txBody>
+      </p:sp>
+      <p:sp>
+        <p:nvSpPr>
+          <p:cNvPr id="45" name="Shape 23"/>
+          <p:cNvSpPr/>
+          <p:nvPr/>
+        </p:nvSpPr>
+        <p:spPr>
+          <a:xfrm>
+            <a:off x="365760" y="493776"/>
+            <a:ext cx="841248" cy="192024"/>
+          </a:xfrm>
+          <a:prstGeom prst="rect">
+            <a:avLst/>
+          </a:prstGeom>
+          <a:solidFill>
+            <a:srgbClr val="3A4750"/>
+          </a:solidFill>
+          <a:ln w="6350">
+            <a:solidFill>
+              <a:srgbClr val="1A1A1A"/>
+            </a:solidFill>
+            <a:prstDash val="solid"/>
+          </a:ln>
+        </p:spPr>
+      </p:sp>
+      <p:sp>
+        <p:nvSpPr>
+          <p:cNvPr id="46" name="Shape 24"/>
+          <p:cNvSpPr/>
+          <p:nvPr/>
+        </p:nvSpPr>
+        <p:spPr>
+          <a:xfrm>
+            <a:off x="1261872" y="493776"/>
+            <a:ext cx="932688" cy="192024"/>
+          </a:xfrm>
+          <a:prstGeom prst="rect">
+            <a:avLst/>
+          </a:prstGeom>
+          <a:solidFill>
+            <a:srgbClr val="0073BA"/>
+          </a:solidFill>
+          <a:ln w="6350">
+            <a:solidFill>
+              <a:srgbClr val="1A1A1A"/>
+            </a:solidFill>
+            <a:prstDash val="solid"/>
+          </a:ln>
+        </p:spPr>
+      </p:sp>
+      <p:sp>
+        <p:nvSpPr>
+          <p:cNvPr id="47" name="Text 25"/>
+          <p:cNvSpPr/>
+          <p:nvPr/>
+        </p:nvSpPr>
+        <p:spPr>
+          <a:xfrm>
+            <a:off x="256032" y="704088"/>
+            <a:ext cx="1060704" cy="182880"/>
+          </a:xfrm>
+          <a:prstGeom prst="rect">
+            <a:avLst/>
+          </a:prstGeom>
+          <a:noFill/>
+          <a:ln/>
+        </p:spPr>
+        <p:txBody>
+          <a:bodyPr wrap="square" lIns="0" tIns="0" rIns="0" bIns="0" rtlCol="0" anchor="ctr"/>
+          <a:lstStyle/>
+          <a:p>
+            <a:pPr algn="ctr" indent="0" marL="0">
+              <a:buNone/>
+            </a:pPr>
+            <a:r>
+              <a:rPr lang="en-US" sz="950" dirty="0">
+                <a:solidFill>
+                  <a:srgbClr val="1A1A1A"/>
+                </a:solidFill>
+                <a:latin typeface="Times New Roman" pitchFamily="34" charset="0"/>
+                <a:ea typeface="Times New Roman" pitchFamily="34" charset="-122"/>
+                <a:cs typeface="Times New Roman" pitchFamily="34" charset="-120"/>
+              </a:rPr>
+              <a:t>cellular UEs</a:t>
+            </a:r>
+            <a:endParaRPr lang="en-US" sz="950" dirty="0"/>
+          </a:p>
+        </p:txBody>
+      </p:sp>
+      <p:sp>
+        <p:nvSpPr>
+          <p:cNvPr id="48" name="Text 26"/>
+          <p:cNvSpPr/>
+          <p:nvPr/>
+        </p:nvSpPr>
+        <p:spPr>
+          <a:xfrm>
+            <a:off x="1216152" y="704088"/>
+            <a:ext cx="1024128" cy="182880"/>
+          </a:xfrm>
+          <a:prstGeom prst="rect">
+            <a:avLst/>
+          </a:prstGeom>
+          <a:noFill/>
+          <a:ln/>
+        </p:spPr>
+        <p:txBody>
+          <a:bodyPr wrap="square" lIns="0" tIns="0" rIns="0" bIns="0" rtlCol="0" anchor="ctr"/>
+          <a:lstStyle/>
+          <a:p>
+            <a:pPr algn="ctr" indent="0" marL="0">
+              <a:buNone/>
+            </a:pPr>
+            <a:r>
+              <a:rPr lang="en-US" sz="950" dirty="0">
+                <a:solidFill>
+                  <a:srgbClr val="1A1A1A"/>
+                </a:solidFill>
+                <a:latin typeface="Times New Roman" pitchFamily="34" charset="0"/>
+                <a:ea typeface="Times New Roman" pitchFamily="34" charset="-122"/>
+                <a:cs typeface="Times New Roman" pitchFamily="34" charset="-120"/>
+              </a:rPr>
+              <a:t>FWA CPEs</a:t>
+            </a:r>
+            <a:endParaRPr lang="en-US" sz="950" dirty="0"/>
+          </a:p>
+        </p:txBody>
+      </p:sp>
+      <p:sp>
+        <p:nvSpPr>
+          <p:cNvPr id="49" name="Shape 27"/>
+          <p:cNvSpPr/>
+          <p:nvPr/>
+        </p:nvSpPr>
+        <p:spPr>
+          <a:xfrm>
+            <a:off x="365760" y="960120"/>
+            <a:ext cx="1828800" cy="0"/>
+          </a:xfrm>
+          <a:prstGeom prst="line">
+            <a:avLst/>
+          </a:prstGeom>
+          <a:noFill/>
+          <a:ln w="9525">
+            <a:solidFill>
+              <a:srgbClr val="1A1A1A"/>
+            </a:solidFill>
+            <a:prstDash val="solid"/>
+            <a:tailEnd type="triangle"/>
+          </a:ln>
+        </p:spPr>
+      </p:sp>
+      <p:sp>
+        <p:nvSpPr>
+          <p:cNvPr id="50" name="Text 28"/>
+          <p:cNvSpPr/>
+          <p:nvPr/>
+        </p:nvSpPr>
+        <p:spPr>
+          <a:xfrm>
+            <a:off x="365760" y="978408"/>
+            <a:ext cx="1828800" cy="182880"/>
+          </a:xfrm>
+          <a:prstGeom prst="rect">
+            <a:avLst/>
+          </a:prstGeom>
+          <a:noFill/>
+          <a:ln/>
+        </p:spPr>
+        <p:txBody>
+          <a:bodyPr wrap="square" lIns="0" tIns="0" rIns="0" bIns="0" rtlCol="0" anchor="ctr"/>
+          <a:lstStyle/>
+          <a:p>
+            <a:pPr algn="ctr" indent="0" marL="0">
+              <a:buNone/>
+            </a:pPr>
+            <a:r>
+              <a:rPr lang="en-US" sz="950" i="1" dirty="0">
+                <a:solidFill>
+                  <a:srgbClr val="1A1A1A"/>
+                </a:solidFill>
+                <a:latin typeface="Times New Roman" pitchFamily="34" charset="0"/>
+                <a:ea typeface="Times New Roman" pitchFamily="34" charset="-122"/>
+                <a:cs typeface="Times New Roman" pitchFamily="34" charset="-120"/>
+              </a:rPr>
+              <a:t>frequency</a:t>
+            </a:r>
+            <a:endParaRPr lang="en-US" sz="950" dirty="0"/>
+          </a:p>
+        </p:txBody>
+      </p:sp>
       <p:pic>
         <p:nvPicPr>
-          <p:cNvPr id="40" name="Image 18" descr="preencoded.png">    </p:cNvPr>
+          <p:cNvPr id="51" name="Image 20" descr="preencoded.png">    </p:cNvPr>
           <p:cNvPicPr>
             <a:picLocks noChangeAspect="1"/>
           </p:cNvPicPr>
           <p:nvPr/>
         </p:nvPicPr>
         <p:blipFill>
-          <a:blip r:embed="rId19"/>
+          <a:blip r:embed="rId21"/>
           <a:stretch>
             <a:fillRect/>
           </a:stretch>
@@ -1952,7 +2298,7 @@
       </p:pic>
       <p:sp>
         <p:nvSpPr>
-          <p:cNvPr id="41" name="Text 20"/>
+          <p:cNvPr id="52" name="Text 29"/>
           <p:cNvSpPr/>
           <p:nvPr/>
         </p:nvSpPr>
@@ -1991,14 +2337,14 @@
       </p:sp>
       <p:pic>
         <p:nvPicPr>
-          <p:cNvPr id="42" name="Image 19" descr="preencoded.png">    </p:cNvPr>
+          <p:cNvPr id="53" name="Image 21" descr="preencoded.png">    </p:cNvPr>
           <p:cNvPicPr>
             <a:picLocks noChangeAspect="1"/>
           </p:cNvPicPr>
           <p:nvPr/>
         </p:nvPicPr>
         <p:blipFill>
-          <a:blip r:embed="rId20"/>
+          <a:blip r:embed="rId22"/>
           <a:stretch>
             <a:fillRect/>
           </a:stretch>
@@ -2015,7 +2361,7 @@
       </p:pic>
       <p:sp>
         <p:nvSpPr>
-          <p:cNvPr id="43" name="Text 21"/>
+          <p:cNvPr id="54" name="Text 30"/>
           <p:cNvSpPr/>
           <p:nvPr/>
         </p:nvSpPr>
@@ -2054,14 +2400,14 @@
       </p:sp>
       <p:pic>
         <p:nvPicPr>
-          <p:cNvPr id="44" name="Image 20" descr="preencoded.png">    </p:cNvPr>
+          <p:cNvPr id="55" name="Image 22" descr="preencoded.png">    </p:cNvPr>
           <p:cNvPicPr>
             <a:picLocks noChangeAspect="1"/>
           </p:cNvPicPr>
           <p:nvPr/>
         </p:nvPicPr>
         <p:blipFill>
-          <a:blip r:embed="rId21"/>
+          <a:blip r:embed="rId23"/>
           <a:stretch>
             <a:fillRect/>
           </a:stretch>
@@ -2078,7 +2424,7 @@
       </p:pic>
       <p:sp>
         <p:nvSpPr>
-          <p:cNvPr id="45" name="Text 22"/>
+          <p:cNvPr id="56" name="Text 31"/>
           <p:cNvSpPr/>
           <p:nvPr/>
         </p:nvSpPr>
@@ -2117,14 +2463,14 @@
       </p:sp>
       <p:pic>
         <p:nvPicPr>
-          <p:cNvPr id="46" name="Image 21" descr="preencoded.png">    </p:cNvPr>
+          <p:cNvPr id="57" name="Image 23" descr="preencoded.png">    </p:cNvPr>
           <p:cNvPicPr>
             <a:picLocks noChangeAspect="1"/>
           </p:cNvPicPr>
           <p:nvPr/>
         </p:nvPicPr>
         <p:blipFill>
-          <a:blip r:embed="rId22"/>
+          <a:blip r:embed="rId24"/>
           <a:stretch>
             <a:fillRect/>
           </a:stretch>
@@ -2141,7 +2487,7 @@
       </p:pic>
       <p:sp>
         <p:nvSpPr>
-          <p:cNvPr id="47" name="Text 23"/>
+          <p:cNvPr id="58" name="Text 32"/>
           <p:cNvSpPr/>
           <p:nvPr/>
         </p:nvSpPr>
@@ -2180,14 +2526,14 @@
       </p:sp>
       <p:pic>
         <p:nvPicPr>
-          <p:cNvPr id="48" name="Image 22" descr="preencoded.png">    </p:cNvPr>
+          <p:cNvPr id="59" name="Image 24" descr="preencoded.png">    </p:cNvPr>
           <p:cNvPicPr>
             <a:picLocks noChangeAspect="1"/>
           </p:cNvPicPr>
           <p:nvPr/>
         </p:nvPicPr>
         <p:blipFill>
-          <a:blip r:embed="rId23"/>
+          <a:blip r:embed="rId25"/>
           <a:stretch>
             <a:fillRect/>
           </a:stretch>
@@ -2204,7 +2550,7 @@
       </p:pic>
       <p:sp>
         <p:nvSpPr>
-          <p:cNvPr id="49" name="Text 24"/>
+          <p:cNvPr id="60" name="Text 33"/>
           <p:cNvSpPr/>
           <p:nvPr/>
         </p:nvSpPr>
@@ -2243,14 +2589,14 @@
       </p:sp>
       <p:pic>
         <p:nvPicPr>
-          <p:cNvPr id="50" name="Image 23" descr="preencoded.png">    </p:cNvPr>
+          <p:cNvPr id="61" name="Image 25" descr="preencoded.png">    </p:cNvPr>
           <p:cNvPicPr>
             <a:picLocks noChangeAspect="1"/>
           </p:cNvPicPr>
           <p:nvPr/>
         </p:nvPicPr>
         <p:blipFill>
-          <a:blip r:embed="rId24"/>
+          <a:blip r:embed="rId26"/>
           <a:stretch>
             <a:fillRect/>
           </a:stretch>
@@ -2267,7 +2613,7 @@
       </p:pic>
       <p:sp>
         <p:nvSpPr>
-          <p:cNvPr id="51" name="Text 25"/>
+          <p:cNvPr id="62" name="Text 34"/>
           <p:cNvSpPr/>
           <p:nvPr/>
         </p:nvSpPr>
@@ -2306,14 +2652,14 @@
       </p:sp>
       <p:pic>
         <p:nvPicPr>
-          <p:cNvPr id="52" name="Image 24" descr="preencoded.png">    </p:cNvPr>
+          <p:cNvPr id="63" name="Image 26" descr="preencoded.png">    </p:cNvPr>
           <p:cNvPicPr>
             <a:picLocks noChangeAspect="1"/>
           </p:cNvPicPr>
           <p:nvPr/>
         </p:nvPicPr>
         <p:blipFill>
-          <a:blip r:embed="rId25"/>
+          <a:blip r:embed="rId27"/>
           <a:stretch>
             <a:fillRect/>
           </a:stretch>
@@ -2330,7 +2676,7 @@
       </p:pic>
       <p:sp>
         <p:nvSpPr>
-          <p:cNvPr id="53" name="Text 26"/>
+          <p:cNvPr id="64" name="Text 35"/>
           <p:cNvSpPr/>
           <p:nvPr/>
         </p:nvSpPr>

</xml_diff>